<commit_message>
feat: adding attention example
</commit_message>
<xml_diff>
--- a/Chapter2Part1.pptx
+++ b/Chapter2Part1.pptx
@@ -5,15 +5,16 @@
     <p:sldMasterId id="2147483648" r:id="rId1"/>
   </p:sldMasterIdLst>
   <p:notesMasterIdLst>
-    <p:notesMasterId r:id="rId8"/>
+    <p:notesMasterId r:id="rId9"/>
   </p:notesMasterIdLst>
   <p:sldIdLst>
     <p:sldId id="256" r:id="rId2"/>
     <p:sldId id="264" r:id="rId3"/>
     <p:sldId id="265" r:id="rId4"/>
     <p:sldId id="266" r:id="rId5"/>
-    <p:sldId id="267" r:id="rId6"/>
-    <p:sldId id="282" r:id="rId7"/>
+    <p:sldId id="283" r:id="rId6"/>
+    <p:sldId id="267" r:id="rId7"/>
+    <p:sldId id="282" r:id="rId8"/>
   </p:sldIdLst>
   <p:sldSz cx="12192000" cy="6858000"/>
   <p:notesSz cx="6858000" cy="9144000"/>
@@ -202,7 +203,7 @@
           <a:p>
             <a:fld id="{5C0B3A27-9F04-9B43-8F88-75ED951A9312}" type="datetimeFigureOut">
               <a:rPr lang="en-US" smtClean="0"/>
-              <a:t>1/2/26</a:t>
+              <a:t>1/4/26</a:t>
             </a:fld>
             <a:endParaRPr lang="en-US"/>
           </a:p>
@@ -544,6 +545,90 @@
     </p:spTree>
     <p:extLst>
       <p:ext uri="{BB962C8B-B14F-4D97-AF65-F5344CB8AC3E}">
+        <p14:creationId xmlns:p14="http://schemas.microsoft.com/office/powerpoint/2010/main" val="1004518579"/>
+      </p:ext>
+    </p:extLst>
+  </p:cSld>
+  <p:clrMapOvr>
+    <a:masterClrMapping/>
+  </p:clrMapOvr>
+</p:notes>
+</file>
+
+<file path=ppt/notesSlides/notesSlide2.xml><?xml version="1.0" encoding="utf-8"?>
+<p:notes xmlns:a="http://schemas.openxmlformats.org/drawingml/2006/main" xmlns:r="http://schemas.openxmlformats.org/officeDocument/2006/relationships" xmlns:p="http://schemas.openxmlformats.org/presentationml/2006/main">
+  <p:cSld>
+    <p:spTree>
+      <p:nvGrpSpPr>
+        <p:cNvPr id="1" name=""/>
+        <p:cNvGrpSpPr/>
+        <p:nvPr/>
+      </p:nvGrpSpPr>
+      <p:grpSpPr>
+        <a:xfrm>
+          <a:off x="0" y="0"/>
+          <a:ext cx="0" cy="0"/>
+          <a:chOff x="0" y="0"/>
+          <a:chExt cx="0" cy="0"/>
+        </a:xfrm>
+      </p:grpSpPr>
+      <p:sp>
+        <p:nvSpPr>
+          <p:cNvPr id="2" name="Slide Image Placeholder 1"/>
+          <p:cNvSpPr>
+            <a:spLocks noGrp="1" noRot="1" noChangeAspect="1"/>
+          </p:cNvSpPr>
+          <p:nvPr>
+            <p:ph type="sldImg"/>
+          </p:nvPr>
+        </p:nvSpPr>
+        <p:spPr/>
+      </p:sp>
+      <p:sp>
+        <p:nvSpPr>
+          <p:cNvPr id="3" name="Notes Placeholder 2"/>
+          <p:cNvSpPr>
+            <a:spLocks noGrp="1"/>
+          </p:cNvSpPr>
+          <p:nvPr>
+            <p:ph type="body" idx="1"/>
+          </p:nvPr>
+        </p:nvSpPr>
+        <p:spPr/>
+        <p:txBody>
+          <a:bodyPr/>
+          <a:lstStyle/>
+          <a:p>
+            <a:endParaRPr lang="en-US" dirty="0"/>
+          </a:p>
+        </p:txBody>
+      </p:sp>
+      <p:sp>
+        <p:nvSpPr>
+          <p:cNvPr id="4" name="Slide Number Placeholder 3"/>
+          <p:cNvSpPr>
+            <a:spLocks noGrp="1"/>
+          </p:cNvSpPr>
+          <p:nvPr>
+            <p:ph type="sldNum" sz="quarter" idx="5"/>
+          </p:nvPr>
+        </p:nvSpPr>
+        <p:spPr/>
+        <p:txBody>
+          <a:bodyPr/>
+          <a:lstStyle/>
+          <a:p>
+            <a:fld id="{C94F8F55-5283-4741-948E-3713C361D960}" type="slidenum">
+              <a:rPr lang="en-US" smtClean="0"/>
+              <a:t>6</a:t>
+            </a:fld>
+            <a:endParaRPr lang="en-US"/>
+          </a:p>
+        </p:txBody>
+      </p:sp>
+    </p:spTree>
+    <p:extLst>
+      <p:ext uri="{BB962C8B-B14F-4D97-AF65-F5344CB8AC3E}">
         <p14:creationId xmlns:p14="http://schemas.microsoft.com/office/powerpoint/2010/main" val="2591582552"/>
       </p:ext>
     </p:extLst>
@@ -703,7 +788,7 @@
           <a:p>
             <a:fld id="{87AB81C4-7F73-9945-A8EE-FBB628EFA778}" type="datetimeFigureOut">
               <a:rPr lang="en-US" smtClean="0"/>
-              <a:t>1/2/26</a:t>
+              <a:t>1/4/26</a:t>
             </a:fld>
             <a:endParaRPr lang="en-US"/>
           </a:p>
@@ -903,7 +988,7 @@
           <a:p>
             <a:fld id="{87AB81C4-7F73-9945-A8EE-FBB628EFA778}" type="datetimeFigureOut">
               <a:rPr lang="en-US" smtClean="0"/>
-              <a:t>1/2/26</a:t>
+              <a:t>1/4/26</a:t>
             </a:fld>
             <a:endParaRPr lang="en-US"/>
           </a:p>
@@ -1113,7 +1198,7 @@
           <a:p>
             <a:fld id="{87AB81C4-7F73-9945-A8EE-FBB628EFA778}" type="datetimeFigureOut">
               <a:rPr lang="en-US" smtClean="0"/>
-              <a:t>1/2/26</a:t>
+              <a:t>1/4/26</a:t>
             </a:fld>
             <a:endParaRPr lang="en-US"/>
           </a:p>
@@ -1313,7 +1398,7 @@
           <a:p>
             <a:fld id="{87AB81C4-7F73-9945-A8EE-FBB628EFA778}" type="datetimeFigureOut">
               <a:rPr lang="en-US" smtClean="0"/>
-              <a:t>1/2/26</a:t>
+              <a:t>1/4/26</a:t>
             </a:fld>
             <a:endParaRPr lang="en-US"/>
           </a:p>
@@ -1589,7 +1674,7 @@
           <a:p>
             <a:fld id="{87AB81C4-7F73-9945-A8EE-FBB628EFA778}" type="datetimeFigureOut">
               <a:rPr lang="en-US" smtClean="0"/>
-              <a:t>1/2/26</a:t>
+              <a:t>1/4/26</a:t>
             </a:fld>
             <a:endParaRPr lang="en-US"/>
           </a:p>
@@ -1857,7 +1942,7 @@
           <a:p>
             <a:fld id="{87AB81C4-7F73-9945-A8EE-FBB628EFA778}" type="datetimeFigureOut">
               <a:rPr lang="en-US" smtClean="0"/>
-              <a:t>1/2/26</a:t>
+              <a:t>1/4/26</a:t>
             </a:fld>
             <a:endParaRPr lang="en-US"/>
           </a:p>
@@ -2272,7 +2357,7 @@
           <a:p>
             <a:fld id="{87AB81C4-7F73-9945-A8EE-FBB628EFA778}" type="datetimeFigureOut">
               <a:rPr lang="en-US" smtClean="0"/>
-              <a:t>1/2/26</a:t>
+              <a:t>1/4/26</a:t>
             </a:fld>
             <a:endParaRPr lang="en-US"/>
           </a:p>
@@ -2414,7 +2499,7 @@
           <a:p>
             <a:fld id="{87AB81C4-7F73-9945-A8EE-FBB628EFA778}" type="datetimeFigureOut">
               <a:rPr lang="en-US" smtClean="0"/>
-              <a:t>1/2/26</a:t>
+              <a:t>1/4/26</a:t>
             </a:fld>
             <a:endParaRPr lang="en-US"/>
           </a:p>
@@ -2527,7 +2612,7 @@
           <a:p>
             <a:fld id="{87AB81C4-7F73-9945-A8EE-FBB628EFA778}" type="datetimeFigureOut">
               <a:rPr lang="en-US" smtClean="0"/>
-              <a:t>1/2/26</a:t>
+              <a:t>1/4/26</a:t>
             </a:fld>
             <a:endParaRPr lang="en-US"/>
           </a:p>
@@ -2840,7 +2925,7 @@
           <a:p>
             <a:fld id="{87AB81C4-7F73-9945-A8EE-FBB628EFA778}" type="datetimeFigureOut">
               <a:rPr lang="en-US" smtClean="0"/>
-              <a:t>1/2/26</a:t>
+              <a:t>1/4/26</a:t>
             </a:fld>
             <a:endParaRPr lang="en-US"/>
           </a:p>
@@ -3129,7 +3214,7 @@
           <a:p>
             <a:fld id="{87AB81C4-7F73-9945-A8EE-FBB628EFA778}" type="datetimeFigureOut">
               <a:rPr lang="en-US" smtClean="0"/>
-              <a:t>1/2/26</a:t>
+              <a:t>1/4/26</a:t>
             </a:fld>
             <a:endParaRPr lang="en-US"/>
           </a:p>
@@ -3372,7 +3457,7 @@
           <a:p>
             <a:fld id="{87AB81C4-7F73-9945-A8EE-FBB628EFA778}" type="datetimeFigureOut">
               <a:rPr lang="en-US" smtClean="0"/>
-              <a:t>1/2/26</a:t>
+              <a:t>1/4/26</a:t>
             </a:fld>
             <a:endParaRPr lang="en-US"/>
           </a:p>
@@ -4985,6 +5070,666 @@
         <p:cNvPr id="1" name="">
           <a:extLst>
             <a:ext uri="{FF2B5EF4-FFF2-40B4-BE49-F238E27FC236}">
+              <a16:creationId xmlns:a16="http://schemas.microsoft.com/office/drawing/2014/main" id="{607ADCCD-A8F0-654A-E601-06B7CF7EE0FB}"/>
+            </a:ext>
+          </a:extLst>
+        </p:cNvPr>
+        <p:cNvGrpSpPr/>
+        <p:nvPr/>
+      </p:nvGrpSpPr>
+      <p:grpSpPr>
+        <a:xfrm>
+          <a:off x="0" y="0"/>
+          <a:ext cx="0" cy="0"/>
+          <a:chOff x="0" y="0"/>
+          <a:chExt cx="0" cy="0"/>
+        </a:xfrm>
+      </p:grpSpPr>
+      <p:sp>
+        <p:nvSpPr>
+          <p:cNvPr id="2" name="Title 1">
+            <a:extLst>
+              <a:ext uri="{FF2B5EF4-FFF2-40B4-BE49-F238E27FC236}">
+                <a16:creationId xmlns:a16="http://schemas.microsoft.com/office/drawing/2014/main" id="{48713BE0-ED4C-ADC6-D502-EC9D52FFF13C}"/>
+              </a:ext>
+            </a:extLst>
+          </p:cNvPr>
+          <p:cNvSpPr>
+            <a:spLocks noGrp="1"/>
+          </p:cNvSpPr>
+          <p:nvPr>
+            <p:ph type="title"/>
+          </p:nvPr>
+        </p:nvSpPr>
+        <p:spPr/>
+        <p:txBody>
+          <a:bodyPr/>
+          <a:lstStyle/>
+          <a:p>
+            <a:r>
+              <a:rPr lang="en-IN" dirty="0"/>
+              <a:t>Attention in Action: An Example</a:t>
+            </a:r>
+            <a:endParaRPr lang="en-US" dirty="0"/>
+          </a:p>
+        </p:txBody>
+      </p:sp>
+      <p:sp>
+        <p:nvSpPr>
+          <p:cNvPr id="5" name="TextBox 4">
+            <a:extLst>
+              <a:ext uri="{FF2B5EF4-FFF2-40B4-BE49-F238E27FC236}">
+                <a16:creationId xmlns:a16="http://schemas.microsoft.com/office/drawing/2014/main" id="{7771D7D1-37CE-D421-C03E-FBEE8FFF1A7E}"/>
+              </a:ext>
+            </a:extLst>
+          </p:cNvPr>
+          <p:cNvSpPr txBox="1"/>
+          <p:nvPr/>
+        </p:nvSpPr>
+        <p:spPr>
+          <a:xfrm>
+            <a:off x="734028" y="1474369"/>
+            <a:ext cx="11353800" cy="369332"/>
+          </a:xfrm>
+          <a:prstGeom prst="rect">
+            <a:avLst/>
+          </a:prstGeom>
+          <a:solidFill>
+            <a:srgbClr val="EDE9E3"/>
+          </a:solidFill>
+          <a:ln>
+            <a:solidFill>
+              <a:schemeClr val="tx1"/>
+            </a:solidFill>
+          </a:ln>
+        </p:spPr>
+        <p:txBody>
+          <a:bodyPr wrap="square" rtlCol="0">
+            <a:spAutoFit/>
+          </a:bodyPr>
+          <a:lstStyle/>
+          <a:p>
+            <a:r>
+              <a:rPr lang="en-IN" b="1" dirty="0"/>
+              <a:t>Query (Q):</a:t>
+            </a:r>
+            <a:r>
+              <a:rPr lang="en-IN" dirty="0"/>
+              <a:t> What am I looking for?	</a:t>
+            </a:r>
+            <a:r>
+              <a:rPr lang="en-IN" b="1" dirty="0"/>
+              <a:t>Key (K):</a:t>
+            </a:r>
+            <a:r>
+              <a:rPr lang="en-IN" dirty="0"/>
+              <a:t> What do I have to offer?	</a:t>
+            </a:r>
+            <a:r>
+              <a:rPr lang="en-IN" b="1" dirty="0"/>
+              <a:t>Value (V):</a:t>
+            </a:r>
+            <a:r>
+              <a:rPr lang="en-IN" dirty="0"/>
+              <a:t> What information can I give?</a:t>
+            </a:r>
+          </a:p>
+        </p:txBody>
+      </p:sp>
+      <p:sp>
+        <p:nvSpPr>
+          <p:cNvPr id="14" name="TextBox 13">
+            <a:extLst>
+              <a:ext uri="{FF2B5EF4-FFF2-40B4-BE49-F238E27FC236}">
+                <a16:creationId xmlns:a16="http://schemas.microsoft.com/office/drawing/2014/main" id="{C721A9AA-EA38-4298-5A41-BB81B3E55B99}"/>
+              </a:ext>
+            </a:extLst>
+          </p:cNvPr>
+          <p:cNvSpPr txBox="1"/>
+          <p:nvPr/>
+        </p:nvSpPr>
+        <p:spPr>
+          <a:xfrm>
+            <a:off x="838200" y="5580166"/>
+            <a:ext cx="6096000" cy="369332"/>
+          </a:xfrm>
+          <a:prstGeom prst="rect">
+            <a:avLst/>
+          </a:prstGeom>
+          <a:noFill/>
+        </p:spPr>
+        <p:txBody>
+          <a:bodyPr wrap="square">
+            <a:spAutoFit/>
+          </a:bodyPr>
+          <a:lstStyle/>
+          <a:p>
+            <a:endParaRPr lang="en-US" b="1" dirty="0"/>
+          </a:p>
+        </p:txBody>
+      </p:sp>
+      <p:sp>
+        <p:nvSpPr>
+          <p:cNvPr id="7" name="TextBox 6">
+            <a:extLst>
+              <a:ext uri="{FF2B5EF4-FFF2-40B4-BE49-F238E27FC236}">
+                <a16:creationId xmlns:a16="http://schemas.microsoft.com/office/drawing/2014/main" id="{26E8C36C-16D5-C827-FFEC-5E39E5B68E8A}"/>
+              </a:ext>
+            </a:extLst>
+          </p:cNvPr>
+          <p:cNvSpPr txBox="1"/>
+          <p:nvPr/>
+        </p:nvSpPr>
+        <p:spPr>
+          <a:xfrm>
+            <a:off x="838200" y="1996714"/>
+            <a:ext cx="10890812" cy="584775"/>
+          </a:xfrm>
+          <a:prstGeom prst="rect">
+            <a:avLst/>
+          </a:prstGeom>
+          <a:noFill/>
+        </p:spPr>
+        <p:txBody>
+          <a:bodyPr wrap="square">
+            <a:spAutoFit/>
+          </a:bodyPr>
+          <a:lstStyle/>
+          <a:p>
+            <a:r>
+              <a:rPr lang="en-IN" sz="1600" b="1" dirty="0"/>
+              <a:t>Problem</a:t>
+            </a:r>
+          </a:p>
+          <a:p>
+            <a:r>
+              <a:rPr lang="en-IN" sz="1600" dirty="0"/>
+              <a:t>In the sentence "The cat sat on the mat", when processing ”cat", the model needs to know which words are relevant to it. </a:t>
+            </a:r>
+            <a:endParaRPr lang="en-IN" sz="1600" b="0" i="0" dirty="0">
+              <a:effectLst/>
+            </a:endParaRPr>
+          </a:p>
+        </p:txBody>
+      </p:sp>
+      <p:pic>
+        <p:nvPicPr>
+          <p:cNvPr id="23" name="Picture 22">
+            <a:extLst>
+              <a:ext uri="{FF2B5EF4-FFF2-40B4-BE49-F238E27FC236}">
+                <a16:creationId xmlns:a16="http://schemas.microsoft.com/office/drawing/2014/main" id="{CA0142A4-440A-BD65-610E-88FF1BF47DA0}"/>
+              </a:ext>
+            </a:extLst>
+          </p:cNvPr>
+          <p:cNvPicPr>
+            <a:picLocks noChangeAspect="1"/>
+          </p:cNvPicPr>
+          <p:nvPr/>
+        </p:nvPicPr>
+        <p:blipFill>
+          <a:blip r:embed="rId3"/>
+          <a:stretch>
+            <a:fillRect/>
+          </a:stretch>
+        </p:blipFill>
+        <p:spPr>
+          <a:xfrm>
+            <a:off x="73890" y="3138821"/>
+            <a:ext cx="1525126" cy="1116329"/>
+          </a:xfrm>
+          <a:prstGeom prst="rect">
+            <a:avLst/>
+          </a:prstGeom>
+          <a:ln>
+            <a:solidFill>
+              <a:schemeClr val="tx1"/>
+            </a:solidFill>
+          </a:ln>
+        </p:spPr>
+      </p:pic>
+      <p:pic>
+        <p:nvPicPr>
+          <p:cNvPr id="28" name="Picture 27">
+            <a:extLst>
+              <a:ext uri="{FF2B5EF4-FFF2-40B4-BE49-F238E27FC236}">
+                <a16:creationId xmlns:a16="http://schemas.microsoft.com/office/drawing/2014/main" id="{0EB98607-F3BF-A442-7BF7-9605FCAFDE65}"/>
+              </a:ext>
+            </a:extLst>
+          </p:cNvPr>
+          <p:cNvPicPr>
+            <a:picLocks noChangeAspect="1"/>
+          </p:cNvPicPr>
+          <p:nvPr/>
+        </p:nvPicPr>
+        <p:blipFill>
+          <a:blip r:embed="rId4"/>
+          <a:stretch>
+            <a:fillRect/>
+          </a:stretch>
+        </p:blipFill>
+        <p:spPr>
+          <a:xfrm>
+            <a:off x="4440793" y="3240411"/>
+            <a:ext cx="3630993" cy="789106"/>
+          </a:xfrm>
+          <a:prstGeom prst="rect">
+            <a:avLst/>
+          </a:prstGeom>
+          <a:ln>
+            <a:solidFill>
+              <a:schemeClr val="tx1"/>
+            </a:solidFill>
+          </a:ln>
+        </p:spPr>
+      </p:pic>
+      <p:pic>
+        <p:nvPicPr>
+          <p:cNvPr id="30" name="Picture 29">
+            <a:extLst>
+              <a:ext uri="{FF2B5EF4-FFF2-40B4-BE49-F238E27FC236}">
+                <a16:creationId xmlns:a16="http://schemas.microsoft.com/office/drawing/2014/main" id="{F9AF989A-A65C-C5F1-9FD5-E7FE31E80780}"/>
+              </a:ext>
+            </a:extLst>
+          </p:cNvPr>
+          <p:cNvPicPr>
+            <a:picLocks noChangeAspect="1"/>
+          </p:cNvPicPr>
+          <p:nvPr/>
+        </p:nvPicPr>
+        <p:blipFill>
+          <a:blip r:embed="rId5"/>
+          <a:stretch>
+            <a:fillRect/>
+          </a:stretch>
+        </p:blipFill>
+        <p:spPr>
+          <a:xfrm>
+            <a:off x="1734600" y="3153417"/>
+            <a:ext cx="2464509" cy="3633669"/>
+          </a:xfrm>
+          <a:prstGeom prst="rect">
+            <a:avLst/>
+          </a:prstGeom>
+          <a:ln>
+            <a:solidFill>
+              <a:schemeClr val="tx1"/>
+            </a:solidFill>
+          </a:ln>
+        </p:spPr>
+      </p:pic>
+      <p:pic>
+        <p:nvPicPr>
+          <p:cNvPr id="31" name="Picture 30">
+            <a:extLst>
+              <a:ext uri="{FF2B5EF4-FFF2-40B4-BE49-F238E27FC236}">
+                <a16:creationId xmlns:a16="http://schemas.microsoft.com/office/drawing/2014/main" id="{B72902F6-6963-2C54-77FE-7EBCC4242D8C}"/>
+              </a:ext>
+            </a:extLst>
+          </p:cNvPr>
+          <p:cNvPicPr>
+            <a:picLocks noChangeAspect="1"/>
+          </p:cNvPicPr>
+          <p:nvPr/>
+        </p:nvPicPr>
+        <p:blipFill>
+          <a:blip r:embed="rId6"/>
+          <a:stretch>
+            <a:fillRect/>
+          </a:stretch>
+        </p:blipFill>
+        <p:spPr>
+          <a:xfrm>
+            <a:off x="4440793" y="4464116"/>
+            <a:ext cx="3111175" cy="2309523"/>
+          </a:xfrm>
+          <a:prstGeom prst="rect">
+            <a:avLst/>
+          </a:prstGeom>
+          <a:ln>
+            <a:solidFill>
+              <a:schemeClr val="tx1"/>
+            </a:solidFill>
+          </a:ln>
+        </p:spPr>
+      </p:pic>
+      <p:pic>
+        <p:nvPicPr>
+          <p:cNvPr id="32" name="Picture 31">
+            <a:extLst>
+              <a:ext uri="{FF2B5EF4-FFF2-40B4-BE49-F238E27FC236}">
+                <a16:creationId xmlns:a16="http://schemas.microsoft.com/office/drawing/2014/main" id="{113050C3-6D69-AEED-3098-102284FF23FC}"/>
+              </a:ext>
+            </a:extLst>
+          </p:cNvPr>
+          <p:cNvPicPr>
+            <a:picLocks noChangeAspect="1"/>
+          </p:cNvPicPr>
+          <p:nvPr/>
+        </p:nvPicPr>
+        <p:blipFill>
+          <a:blip r:embed="rId7"/>
+          <a:stretch>
+            <a:fillRect/>
+          </a:stretch>
+        </p:blipFill>
+        <p:spPr>
+          <a:xfrm>
+            <a:off x="8198883" y="3152884"/>
+            <a:ext cx="3413519" cy="1356464"/>
+          </a:xfrm>
+          <a:prstGeom prst="rect">
+            <a:avLst/>
+          </a:prstGeom>
+          <a:ln>
+            <a:solidFill>
+              <a:schemeClr val="tx1"/>
+            </a:solidFill>
+          </a:ln>
+        </p:spPr>
+      </p:pic>
+      <p:sp>
+        <p:nvSpPr>
+          <p:cNvPr id="33" name="TextBox 32">
+            <a:extLst>
+              <a:ext uri="{FF2B5EF4-FFF2-40B4-BE49-F238E27FC236}">
+                <a16:creationId xmlns:a16="http://schemas.microsoft.com/office/drawing/2014/main" id="{C6A4E325-577C-07E4-765F-6A336AA14D32}"/>
+              </a:ext>
+            </a:extLst>
+          </p:cNvPr>
+          <p:cNvSpPr txBox="1"/>
+          <p:nvPr/>
+        </p:nvSpPr>
+        <p:spPr>
+          <a:xfrm>
+            <a:off x="209474" y="2820695"/>
+            <a:ext cx="1202573" cy="246221"/>
+          </a:xfrm>
+          <a:prstGeom prst="rect">
+            <a:avLst/>
+          </a:prstGeom>
+          <a:noFill/>
+        </p:spPr>
+        <p:txBody>
+          <a:bodyPr wrap="none" rtlCol="0">
+            <a:spAutoFit/>
+          </a:bodyPr>
+          <a:lstStyle/>
+          <a:p>
+            <a:r>
+              <a:rPr lang="en-US" sz="1000" dirty="0"/>
+              <a:t>Embedding Vector</a:t>
+            </a:r>
+          </a:p>
+        </p:txBody>
+      </p:sp>
+      <p:sp>
+        <p:nvSpPr>
+          <p:cNvPr id="34" name="TextBox 33">
+            <a:extLst>
+              <a:ext uri="{FF2B5EF4-FFF2-40B4-BE49-F238E27FC236}">
+                <a16:creationId xmlns:a16="http://schemas.microsoft.com/office/drawing/2014/main" id="{46593799-827B-7E53-C0A5-D23A2DF897AC}"/>
+              </a:ext>
+            </a:extLst>
+          </p:cNvPr>
+          <p:cNvSpPr txBox="1"/>
+          <p:nvPr/>
+        </p:nvSpPr>
+        <p:spPr>
+          <a:xfrm>
+            <a:off x="1881037" y="2724850"/>
+            <a:ext cx="2559756" cy="400110"/>
+          </a:xfrm>
+          <a:prstGeom prst="rect">
+            <a:avLst/>
+          </a:prstGeom>
+          <a:noFill/>
+        </p:spPr>
+        <p:txBody>
+          <a:bodyPr wrap="square" rtlCol="0">
+            <a:spAutoFit/>
+          </a:bodyPr>
+          <a:lstStyle/>
+          <a:p>
+            <a:r>
+              <a:rPr lang="en-IN" sz="1000" dirty="0"/>
+              <a:t>Assuming simplified weight matrices, calculate queries, keys, and values:</a:t>
+            </a:r>
+            <a:endParaRPr lang="en-US" sz="1000" dirty="0"/>
+          </a:p>
+        </p:txBody>
+      </p:sp>
+      <p:sp>
+        <p:nvSpPr>
+          <p:cNvPr id="36" name="TextBox 35">
+            <a:extLst>
+              <a:ext uri="{FF2B5EF4-FFF2-40B4-BE49-F238E27FC236}">
+                <a16:creationId xmlns:a16="http://schemas.microsoft.com/office/drawing/2014/main" id="{28981AC7-55D7-51AF-22C7-2C38172A34D6}"/>
+              </a:ext>
+            </a:extLst>
+          </p:cNvPr>
+          <p:cNvSpPr txBox="1"/>
+          <p:nvPr/>
+        </p:nvSpPr>
+        <p:spPr>
+          <a:xfrm>
+            <a:off x="4440793" y="2752074"/>
+            <a:ext cx="3516406" cy="400110"/>
+          </a:xfrm>
+          <a:prstGeom prst="rect">
+            <a:avLst/>
+          </a:prstGeom>
+          <a:noFill/>
+        </p:spPr>
+        <p:txBody>
+          <a:bodyPr wrap="square">
+            <a:spAutoFit/>
+          </a:bodyPr>
+          <a:lstStyle/>
+          <a:p>
+            <a:pPr>
+              <a:buNone/>
+            </a:pPr>
+            <a:r>
+              <a:rPr lang="en-IN" sz="1000" dirty="0"/>
+              <a:t>"How much should the query from 'cat' attend to each key?"</a:t>
+            </a:r>
+          </a:p>
+          <a:p>
+            <a:pPr>
+              <a:buNone/>
+            </a:pPr>
+            <a:r>
+              <a:rPr lang="en-IN" sz="1000" dirty="0"/>
+              <a:t>This is done with a </a:t>
+            </a:r>
+            <a:r>
+              <a:rPr lang="en-IN" sz="1000" b="1" dirty="0"/>
+              <a:t>dot product</a:t>
+            </a:r>
+            <a:r>
+              <a:rPr lang="en-IN" sz="1000" dirty="0"/>
+              <a:t> between Q and each K:</a:t>
+            </a:r>
+          </a:p>
+        </p:txBody>
+      </p:sp>
+      <p:sp>
+        <p:nvSpPr>
+          <p:cNvPr id="38" name="TextBox 37">
+            <a:extLst>
+              <a:ext uri="{FF2B5EF4-FFF2-40B4-BE49-F238E27FC236}">
+                <a16:creationId xmlns:a16="http://schemas.microsoft.com/office/drawing/2014/main" id="{FEAD8236-7EA5-928E-2E0E-557A6E2536D0}"/>
+              </a:ext>
+            </a:extLst>
+          </p:cNvPr>
+          <p:cNvSpPr txBox="1"/>
+          <p:nvPr/>
+        </p:nvSpPr>
+        <p:spPr>
+          <a:xfrm>
+            <a:off x="4440793" y="4099858"/>
+            <a:ext cx="3516406" cy="246221"/>
+          </a:xfrm>
+          <a:prstGeom prst="rect">
+            <a:avLst/>
+          </a:prstGeom>
+          <a:noFill/>
+        </p:spPr>
+        <p:txBody>
+          <a:bodyPr wrap="square">
+            <a:spAutoFit/>
+          </a:bodyPr>
+          <a:lstStyle/>
+          <a:p>
+            <a:r>
+              <a:rPr lang="en-IN" sz="1000" dirty="0"/>
+              <a:t>We convert these scores to probabilities so they sum to 1:</a:t>
+            </a:r>
+            <a:endParaRPr lang="en-US" sz="1000" dirty="0"/>
+          </a:p>
+        </p:txBody>
+      </p:sp>
+      <p:sp>
+        <p:nvSpPr>
+          <p:cNvPr id="40" name="TextBox 39">
+            <a:extLst>
+              <a:ext uri="{FF2B5EF4-FFF2-40B4-BE49-F238E27FC236}">
+                <a16:creationId xmlns:a16="http://schemas.microsoft.com/office/drawing/2014/main" id="{B8EFDCAF-DC97-C28D-B891-E0B80E0657A3}"/>
+              </a:ext>
+            </a:extLst>
+          </p:cNvPr>
+          <p:cNvSpPr txBox="1"/>
+          <p:nvPr/>
+        </p:nvSpPr>
+        <p:spPr>
+          <a:xfrm>
+            <a:off x="8299091" y="4989711"/>
+            <a:ext cx="3213101" cy="400110"/>
+          </a:xfrm>
+          <a:prstGeom prst="rect">
+            <a:avLst/>
+          </a:prstGeom>
+          <a:noFill/>
+        </p:spPr>
+        <p:txBody>
+          <a:bodyPr wrap="square">
+            <a:spAutoFit/>
+          </a:bodyPr>
+          <a:lstStyle/>
+          <a:p>
+            <a:r>
+              <a:rPr lang="en-IN" sz="1000" b="1" i="1" dirty="0"/>
+              <a:t>The word "cat" attended most strongly to itself (0.24) and to "on" (0.24)</a:t>
+            </a:r>
+            <a:endParaRPr lang="en-US" sz="1000" b="1" i="1" dirty="0"/>
+          </a:p>
+        </p:txBody>
+      </p:sp>
+      <p:pic>
+        <p:nvPicPr>
+          <p:cNvPr id="41" name="Picture 40">
+            <a:extLst>
+              <a:ext uri="{FF2B5EF4-FFF2-40B4-BE49-F238E27FC236}">
+                <a16:creationId xmlns:a16="http://schemas.microsoft.com/office/drawing/2014/main" id="{38CC09AE-04A3-25BE-E487-A2227DBDBB92}"/>
+              </a:ext>
+            </a:extLst>
+          </p:cNvPr>
+          <p:cNvPicPr>
+            <a:picLocks noChangeAspect="1"/>
+          </p:cNvPicPr>
+          <p:nvPr/>
+        </p:nvPicPr>
+        <p:blipFill>
+          <a:blip r:embed="rId8"/>
+          <a:stretch>
+            <a:fillRect/>
+          </a:stretch>
+        </p:blipFill>
+        <p:spPr>
+          <a:xfrm>
+            <a:off x="10151131" y="6304062"/>
+            <a:ext cx="1825249" cy="460801"/>
+          </a:xfrm>
+          <a:prstGeom prst="rect">
+            <a:avLst/>
+          </a:prstGeom>
+          <a:ln>
+            <a:solidFill>
+              <a:schemeClr val="tx1"/>
+            </a:solidFill>
+          </a:ln>
+        </p:spPr>
+      </p:pic>
+      <p:sp>
+        <p:nvSpPr>
+          <p:cNvPr id="42" name="TextBox 41">
+            <a:extLst>
+              <a:ext uri="{FF2B5EF4-FFF2-40B4-BE49-F238E27FC236}">
+                <a16:creationId xmlns:a16="http://schemas.microsoft.com/office/drawing/2014/main" id="{396271BF-5CF8-36CA-7256-22279610F428}"/>
+              </a:ext>
+            </a:extLst>
+          </p:cNvPr>
+          <p:cNvSpPr txBox="1"/>
+          <p:nvPr/>
+        </p:nvSpPr>
+        <p:spPr>
+          <a:xfrm>
+            <a:off x="8071786" y="6054632"/>
+            <a:ext cx="2472152" cy="246221"/>
+          </a:xfrm>
+          <a:prstGeom prst="rect">
+            <a:avLst/>
+          </a:prstGeom>
+          <a:noFill/>
+        </p:spPr>
+        <p:txBody>
+          <a:bodyPr wrap="none" rtlCol="0">
+            <a:spAutoFit/>
+          </a:bodyPr>
+          <a:lstStyle/>
+          <a:p>
+            <a:r>
+              <a:rPr lang="en-US" sz="1000" dirty="0">
+                <a:solidFill>
+                  <a:schemeClr val="bg2">
+                    <a:lumMod val="50000"/>
+                  </a:schemeClr>
+                </a:solidFill>
+              </a:rPr>
+              <a:t>The entire calculation here encapsulates:</a:t>
+            </a:r>
+          </a:p>
+        </p:txBody>
+      </p:sp>
+    </p:spTree>
+    <p:extLst>
+      <p:ext uri="{BB962C8B-B14F-4D97-AF65-F5344CB8AC3E}">
+        <p14:creationId xmlns:p14="http://schemas.microsoft.com/office/powerpoint/2010/main" val="3803487189"/>
+      </p:ext>
+    </p:extLst>
+  </p:cSld>
+  <p:clrMapOvr>
+    <a:masterClrMapping/>
+  </p:clrMapOvr>
+</p:sld>
+</file>
+
+<file path=ppt/slides/slide6.xml><?xml version="1.0" encoding="utf-8"?>
+<p:sld xmlns:a="http://schemas.openxmlformats.org/drawingml/2006/main" xmlns:r="http://schemas.openxmlformats.org/officeDocument/2006/relationships" xmlns:p="http://schemas.openxmlformats.org/presentationml/2006/main">
+  <p:cSld>
+    <p:bg>
+      <p:bgPr>
+        <a:solidFill>
+          <a:srgbClr val="F7F6F2"/>
+        </a:solidFill>
+        <a:effectLst/>
+      </p:bgPr>
+    </p:bg>
+    <p:spTree>
+      <p:nvGrpSpPr>
+        <p:cNvPr id="1" name="">
+          <a:extLst>
+            <a:ext uri="{FF2B5EF4-FFF2-40B4-BE49-F238E27FC236}">
               <a16:creationId xmlns:a16="http://schemas.microsoft.com/office/drawing/2014/main" id="{F6B076EC-4181-B0A5-3EDF-86F1C95AC0D8}"/>
             </a:ext>
           </a:extLst>
@@ -5394,7 +6139,7 @@
 </p:sld>
 </file>
 
-<file path=ppt/slides/slide6.xml><?xml version="1.0" encoding="utf-8"?>
+<file path=ppt/slides/slide7.xml><?xml version="1.0" encoding="utf-8"?>
 <p:sld xmlns:a="http://schemas.openxmlformats.org/drawingml/2006/main" xmlns:r="http://schemas.openxmlformats.org/officeDocument/2006/relationships" xmlns:p="http://schemas.openxmlformats.org/presentationml/2006/main">
   <p:cSld>
     <p:bg>

</xml_diff>